<commit_message>
Ajout d'exercice de colle 3
</commit_message>
<xml_diff>
--- a/01_ModelisationAM/Colle_02_AM/images/Figures.pptx
+++ b/01_ModelisationAM/Colle_02_AM/images/Figures.pptx
@@ -6,7 +6,8 @@
   </p:sldMasterIdLst>
   <p:sldIdLst>
     <p:sldId id="256" r:id="rId2"/>
-    <p:sldId id="257" r:id="rId3"/>
+    <p:sldId id="258" r:id="rId3"/>
+    <p:sldId id="257" r:id="rId4"/>
   </p:sldIdLst>
   <p:sldSz cx="9144000" cy="6858000" type="screen4x3"/>
   <p:notesSz cx="6858000" cy="9144000"/>
@@ -3060,44 +3061,6 @@
           <a:chExt cx="0" cy="0"/>
         </a:xfrm>
       </p:grpSpPr>
-      <p:sp>
-        <p:nvSpPr>
-          <p:cNvPr id="4" name="Triangle isocèle 3"/>
-          <p:cNvSpPr/>
-          <p:nvPr/>
-        </p:nvSpPr>
-        <p:spPr>
-          <a:xfrm rot="10800000">
-            <a:off x="1000100" y="2714620"/>
-            <a:ext cx="1357322" cy="1500198"/>
-          </a:xfrm>
-          <a:prstGeom prst="triangle">
-            <a:avLst/>
-          </a:prstGeom>
-        </p:spPr>
-        <p:style>
-          <a:lnRef idx="1">
-            <a:schemeClr val="accent1"/>
-          </a:lnRef>
-          <a:fillRef idx="2">
-            <a:schemeClr val="accent1"/>
-          </a:fillRef>
-          <a:effectRef idx="1">
-            <a:schemeClr val="accent1"/>
-          </a:effectRef>
-          <a:fontRef idx="minor">
-            <a:schemeClr val="dk1"/>
-          </a:fontRef>
-        </p:style>
-        <p:txBody>
-          <a:bodyPr rtlCol="0" anchor="ctr"/>
-          <a:lstStyle/>
-          <a:p>
-            <a:pPr algn="ctr"/>
-            <a:endParaRPr lang="fr-FR"/>
-          </a:p>
-        </p:txBody>
-      </p:sp>
       <p:cxnSp>
         <p:nvCxnSpPr>
           <p:cNvPr id="6" name="Connecteur droit avec flèche 5"/>
@@ -3105,8 +3068,8 @@
           <p:nvPr/>
         </p:nvCxnSpPr>
         <p:spPr>
-          <a:xfrm flipV="1">
-            <a:off x="1678761" y="2328722"/>
+          <a:xfrm rot="5400000" flipV="1">
+            <a:off x="4762099" y="3094885"/>
             <a:ext cx="0" cy="2108390"/>
           </a:xfrm>
           <a:prstGeom prst="straightConnector1">
@@ -3134,16 +3097,142 @@
           </a:fontRef>
         </p:style>
       </p:cxnSp>
+      <p:sp>
+        <p:nvSpPr>
+          <p:cNvPr id="15" name="ZoneTexte 14"/>
+          <p:cNvSpPr txBox="1"/>
+          <p:nvPr/>
+        </p:nvSpPr>
+        <p:spPr>
+          <a:xfrm>
+            <a:off x="4932040" y="2915965"/>
+            <a:ext cx="214314" cy="307777"/>
+          </a:xfrm>
+          <a:prstGeom prst="rect">
+            <a:avLst/>
+          </a:prstGeom>
+          <a:noFill/>
+        </p:spPr>
+        <p:txBody>
+          <a:bodyPr wrap="square" rtlCol="0">
+            <a:spAutoFit/>
+          </a:bodyPr>
+          <a:lstStyle/>
+          <a:p>
+            <a:r>
+              <a:rPr lang="fr-FR" sz="1400" i="1" dirty="0" smtClean="0"/>
+              <a:t>r</a:t>
+            </a:r>
+            <a:endParaRPr lang="fr-FR" sz="1400" i="1" dirty="0"/>
+          </a:p>
+        </p:txBody>
+      </p:sp>
+      <mc:AlternateContent xmlns:mc="http://schemas.openxmlformats.org/markup-compatibility/2006">
+        <mc:Choice xmlns:a14="http://schemas.microsoft.com/office/drawing/2010/main" Requires="a14">
+          <p:sp>
+            <p:nvSpPr>
+              <p:cNvPr id="8" name="ZoneTexte 7"/>
+              <p:cNvSpPr txBox="1"/>
+              <p:nvPr/>
+            </p:nvSpPr>
+            <p:spPr>
+              <a:xfrm>
+                <a:off x="5816294" y="3995191"/>
+                <a:ext cx="328808" cy="307777"/>
+              </a:xfrm>
+              <a:prstGeom prst="rect">
+                <a:avLst/>
+              </a:prstGeom>
+              <a:noFill/>
+            </p:spPr>
+            <p:txBody>
+              <a:bodyPr wrap="none" rtlCol="0">
+                <a:spAutoFit/>
+              </a:bodyPr>
+              <a:lstStyle/>
+              <a:p>
+                <a:pPr/>
+                <a14:m>
+                  <m:oMathPara xmlns:m="http://schemas.openxmlformats.org/officeDocument/2006/math">
+                    <m:oMathParaPr>
+                      <m:jc m:val="centerGroup"/>
+                    </m:oMathParaPr>
+                    <m:oMath xmlns:m="http://schemas.openxmlformats.org/officeDocument/2006/math">
+                      <m:acc>
+                        <m:accPr>
+                          <m:chr m:val="⃗"/>
+                          <m:ctrlPr>
+                            <a:rPr lang="fr-FR" sz="1400" i="1" smtClean="0">
+                              <a:latin typeface="Cambria Math"/>
+                            </a:rPr>
+                          </m:ctrlPr>
+                        </m:accPr>
+                        <m:e>
+                          <m:r>
+                            <a:rPr lang="fr-FR" sz="1400" b="0" i="1" smtClean="0">
+                              <a:latin typeface="Cambria Math"/>
+                            </a:rPr>
+                            <m:t>𝑦</m:t>
+                          </m:r>
+                        </m:e>
+                      </m:acc>
+                    </m:oMath>
+                  </m:oMathPara>
+                </a14:m>
+                <a:endParaRPr lang="fr-FR" sz="1400" dirty="0"/>
+              </a:p>
+            </p:txBody>
+          </p:sp>
+        </mc:Choice>
+        <mc:Fallback>
+          <p:sp>
+            <p:nvSpPr>
+              <p:cNvPr id="8" name="ZoneTexte 7"/>
+              <p:cNvSpPr txBox="1">
+                <a:spLocks noRot="1" noChangeAspect="1" noMove="1" noResize="1" noEditPoints="1" noAdjustHandles="1" noChangeArrowheads="1" noChangeShapeType="1" noTextEdit="1"/>
+              </p:cNvSpPr>
+              <p:nvPr/>
+            </p:nvSpPr>
+            <p:spPr>
+              <a:xfrm>
+                <a:off x="5816294" y="3995191"/>
+                <a:ext cx="328808" cy="307777"/>
+              </a:xfrm>
+              <a:prstGeom prst="rect">
+                <a:avLst/>
+              </a:prstGeom>
+              <a:blipFill rotWithShape="1">
+                <a:blip r:embed="rId2"/>
+                <a:stretch>
+                  <a:fillRect t="-11765" r="-14815"/>
+                </a:stretch>
+              </a:blipFill>
+            </p:spPr>
+            <p:txBody>
+              <a:bodyPr/>
+              <a:lstStyle/>
+              <a:p>
+                <a:r>
+                  <a:rPr lang="fr-FR">
+                    <a:noFill/>
+                  </a:rPr>
+                  <a:t> </a:t>
+                </a:r>
+              </a:p>
+            </p:txBody>
+          </p:sp>
+        </mc:Fallback>
+      </mc:AlternateContent>
       <p:cxnSp>
         <p:nvCxnSpPr>
-          <p:cNvPr id="9" name="Connecteur droit avec flèche 8"/>
+          <p:cNvPr id="10" name="Connecteur droit avec flèche 9"/>
           <p:cNvCxnSpPr/>
           <p:nvPr/>
         </p:nvCxnSpPr>
         <p:spPr>
-          <a:xfrm>
-            <a:off x="1000102" y="4215612"/>
-            <a:ext cx="1500989" cy="0"/>
+          <a:xfrm flipV="1">
+            <a:off x="3851920" y="2176393"/>
+            <a:ext cx="0" cy="2108390"/>
           </a:xfrm>
           <a:prstGeom prst="straightConnector1">
             <a:avLst/>
@@ -3170,151 +3259,17 @@
           </a:fontRef>
         </p:style>
       </p:cxnSp>
-      <p:cxnSp>
-        <p:nvCxnSpPr>
-          <p:cNvPr id="13" name="Connecteur droit avec flèche 12"/>
-          <p:cNvCxnSpPr/>
-          <p:nvPr/>
-        </p:nvCxnSpPr>
-        <p:spPr>
-          <a:xfrm>
-            <a:off x="1000102" y="2643184"/>
-            <a:ext cx="678659" cy="1587"/>
-          </a:xfrm>
-          <a:prstGeom prst="straightConnector1">
-            <a:avLst/>
-          </a:prstGeom>
-          <a:ln>
-            <a:solidFill>
-              <a:srgbClr val="002060"/>
-            </a:solidFill>
-            <a:headEnd type="stealth" w="med" len="lg"/>
-            <a:tailEnd type="stealth" w="med" len="lg"/>
-          </a:ln>
-        </p:spPr>
-        <p:style>
-          <a:lnRef idx="1">
-            <a:schemeClr val="accent1"/>
-          </a:lnRef>
-          <a:fillRef idx="0">
-            <a:schemeClr val="accent1"/>
-          </a:fillRef>
-          <a:effectRef idx="0">
-            <a:schemeClr val="accent1"/>
-          </a:effectRef>
-          <a:fontRef idx="minor">
-            <a:schemeClr val="tx1"/>
-          </a:fontRef>
-        </p:style>
-      </p:cxnSp>
-      <p:sp>
-        <p:nvSpPr>
-          <p:cNvPr id="15" name="ZoneTexte 14"/>
-          <p:cNvSpPr txBox="1"/>
-          <p:nvPr/>
-        </p:nvSpPr>
-        <p:spPr>
-          <a:xfrm>
-            <a:off x="1214414" y="2352575"/>
-            <a:ext cx="214314" cy="307777"/>
-          </a:xfrm>
-          <a:prstGeom prst="rect">
-            <a:avLst/>
-          </a:prstGeom>
-          <a:noFill/>
-        </p:spPr>
-        <p:txBody>
-          <a:bodyPr wrap="square" rtlCol="0">
-            <a:spAutoFit/>
-          </a:bodyPr>
-          <a:lstStyle/>
-          <a:p>
-            <a:r>
-              <a:rPr lang="fr-FR" sz="1400" i="1" dirty="0" smtClean="0"/>
-              <a:t>r</a:t>
-            </a:r>
-            <a:endParaRPr lang="fr-FR" sz="1400" i="1" dirty="0"/>
-          </a:p>
-        </p:txBody>
-      </p:sp>
-      <p:sp>
-        <p:nvSpPr>
-          <p:cNvPr id="16" name="ZoneTexte 15"/>
-          <p:cNvSpPr txBox="1"/>
-          <p:nvPr/>
-        </p:nvSpPr>
-        <p:spPr>
-          <a:xfrm>
-            <a:off x="2580360" y="3230588"/>
-            <a:ext cx="214314" cy="307777"/>
-          </a:xfrm>
-          <a:prstGeom prst="rect">
-            <a:avLst/>
-          </a:prstGeom>
-          <a:noFill/>
-        </p:spPr>
-        <p:txBody>
-          <a:bodyPr wrap="square" rtlCol="0">
-            <a:spAutoFit/>
-          </a:bodyPr>
-          <a:lstStyle/>
-          <a:p>
-            <a:r>
-              <a:rPr lang="fr-FR" sz="1400" i="1" dirty="0" smtClean="0"/>
-              <a:t>h</a:t>
-            </a:r>
-            <a:endParaRPr lang="fr-FR" sz="1400" i="1" dirty="0"/>
-          </a:p>
-        </p:txBody>
-      </p:sp>
-      <p:cxnSp>
-        <p:nvCxnSpPr>
-          <p:cNvPr id="17" name="Connecteur droit avec flèche 16"/>
-          <p:cNvCxnSpPr/>
-          <p:nvPr/>
-        </p:nvCxnSpPr>
-        <p:spPr>
-          <a:xfrm rot="5400000" flipH="1" flipV="1">
-            <a:off x="1786712" y="3483346"/>
-            <a:ext cx="1571636" cy="1588"/>
-          </a:xfrm>
-          <a:prstGeom prst="straightConnector1">
-            <a:avLst/>
-          </a:prstGeom>
-          <a:ln>
-            <a:solidFill>
-              <a:srgbClr val="002060"/>
-            </a:solidFill>
-            <a:headEnd type="stealth" w="med" len="lg"/>
-            <a:tailEnd type="stealth" w="med" len="lg"/>
-          </a:ln>
-        </p:spPr>
-        <p:style>
-          <a:lnRef idx="1">
-            <a:schemeClr val="accent1"/>
-          </a:lnRef>
-          <a:fillRef idx="0">
-            <a:schemeClr val="accent1"/>
-          </a:fillRef>
-          <a:effectRef idx="0">
-            <a:schemeClr val="accent1"/>
-          </a:effectRef>
-          <a:fontRef idx="minor">
-            <a:schemeClr val="tx1"/>
-          </a:fontRef>
-        </p:style>
-      </p:cxnSp>
       <mc:AlternateContent xmlns:mc="http://schemas.openxmlformats.org/markup-compatibility/2006">
         <mc:Choice xmlns:a14="http://schemas.microsoft.com/office/drawing/2010/main" Requires="a14">
           <p:sp>
             <p:nvSpPr>
-              <p:cNvPr id="8" name="ZoneTexte 7"/>
+              <p:cNvPr id="11" name="ZoneTexte 10"/>
               <p:cNvSpPr txBox="1"/>
               <p:nvPr/>
             </p:nvSpPr>
             <p:spPr>
               <a:xfrm>
-                <a:off x="1637668" y="2242912"/>
+                <a:off x="3851920" y="2074216"/>
                 <a:ext cx="314381" cy="307777"/>
               </a:xfrm>
               <a:prstGeom prst="rect">
@@ -3328,6 +3283,7 @@
               </a:bodyPr>
               <a:lstStyle/>
               <a:p>
+                <a:pPr/>
                 <a14:m>
                   <m:oMathPara xmlns:m="http://schemas.openxmlformats.org/officeDocument/2006/math">
                     <m:oMathParaPr>
@@ -3363,6 +3319,246 @@
         <mc:Fallback>
           <p:sp>
             <p:nvSpPr>
+              <p:cNvPr id="11" name="ZoneTexte 10"/>
+              <p:cNvSpPr txBox="1">
+                <a:spLocks noRot="1" noChangeAspect="1" noMove="1" noResize="1" noEditPoints="1" noAdjustHandles="1" noChangeArrowheads="1" noChangeShapeType="1" noTextEdit="1"/>
+              </p:cNvSpPr>
+              <p:nvPr/>
+            </p:nvSpPr>
+            <p:spPr>
+              <a:xfrm>
+                <a:off x="3851920" y="2074216"/>
+                <a:ext cx="314381" cy="307777"/>
+              </a:xfrm>
+              <a:prstGeom prst="rect">
+                <a:avLst/>
+              </a:prstGeom>
+              <a:blipFill rotWithShape="1">
+                <a:blip r:embed="rId3"/>
+                <a:stretch>
+                  <a:fillRect t="-11765" r="-11765"/>
+                </a:stretch>
+              </a:blipFill>
+            </p:spPr>
+            <p:txBody>
+              <a:bodyPr/>
+              <a:lstStyle/>
+              <a:p>
+                <a:r>
+                  <a:rPr lang="fr-FR">
+                    <a:noFill/>
+                  </a:rPr>
+                  <a:t> </a:t>
+                </a:r>
+              </a:p>
+            </p:txBody>
+          </p:sp>
+        </mc:Fallback>
+      </mc:AlternateContent>
+      <p:sp>
+        <p:nvSpPr>
+          <p:cNvPr id="12" name="Arc 11"/>
+          <p:cNvSpPr/>
+          <p:nvPr/>
+        </p:nvSpPr>
+        <p:spPr>
+          <a:xfrm>
+            <a:off x="2441228" y="2723496"/>
+            <a:ext cx="2850852" cy="2851168"/>
+          </a:xfrm>
+          <a:prstGeom prst="arc">
+            <a:avLst>
+              <a:gd name="adj1" fmla="val 16168151"/>
+              <a:gd name="adj2" fmla="val 30465"/>
+            </a:avLst>
+          </a:prstGeom>
+          <a:ln w="9525">
+            <a:solidFill>
+              <a:srgbClr val="002060"/>
+            </a:solidFill>
+          </a:ln>
+        </p:spPr>
+        <p:style>
+          <a:lnRef idx="1">
+            <a:schemeClr val="accent1"/>
+          </a:lnRef>
+          <a:fillRef idx="0">
+            <a:schemeClr val="accent1"/>
+          </a:fillRef>
+          <a:effectRef idx="0">
+            <a:schemeClr val="accent1"/>
+          </a:effectRef>
+          <a:fontRef idx="minor">
+            <a:schemeClr val="tx1"/>
+          </a:fontRef>
+        </p:style>
+        <p:txBody>
+          <a:bodyPr rtlCol="0" anchor="ctr"/>
+          <a:lstStyle/>
+          <a:p>
+            <a:pPr algn="ctr"/>
+            <a:endParaRPr lang="fr-FR"/>
+          </a:p>
+        </p:txBody>
+      </p:sp>
+      <p:cxnSp>
+        <p:nvCxnSpPr>
+          <p:cNvPr id="18" name="Connecteur droit 17"/>
+          <p:cNvCxnSpPr/>
+          <p:nvPr/>
+        </p:nvCxnSpPr>
+        <p:spPr>
+          <a:xfrm flipH="1">
+            <a:off x="3851920" y="3152537"/>
+            <a:ext cx="1008112" cy="996542"/>
+          </a:xfrm>
+          <a:prstGeom prst="line">
+            <a:avLst/>
+          </a:prstGeom>
+          <a:ln>
+            <a:solidFill>
+              <a:srgbClr val="002060"/>
+            </a:solidFill>
+            <a:headEnd type="stealth" w="med" len="lg"/>
+            <a:tailEnd type="none" w="med" len="lg"/>
+          </a:ln>
+        </p:spPr>
+        <p:style>
+          <a:lnRef idx="1">
+            <a:schemeClr val="accent1"/>
+          </a:lnRef>
+          <a:fillRef idx="0">
+            <a:schemeClr val="accent1"/>
+          </a:fillRef>
+          <a:effectRef idx="0">
+            <a:schemeClr val="accent1"/>
+          </a:effectRef>
+          <a:fontRef idx="minor">
+            <a:schemeClr val="tx1"/>
+          </a:fontRef>
+        </p:style>
+      </p:cxnSp>
+    </p:spTree>
+  </p:cSld>
+  <p:clrMapOvr>
+    <a:masterClrMapping/>
+  </p:clrMapOvr>
+</p:sld>
+</file>
+
+<file path=ppt/slides/slide2.xml><?xml version="1.0" encoding="utf-8"?>
+<p:sld xmlns:a="http://schemas.openxmlformats.org/drawingml/2006/main" xmlns:r="http://schemas.openxmlformats.org/officeDocument/2006/relationships" xmlns:p="http://schemas.openxmlformats.org/presentationml/2006/main">
+  <p:cSld>
+    <p:spTree>
+      <p:nvGrpSpPr>
+        <p:cNvPr id="1" name=""/>
+        <p:cNvGrpSpPr/>
+        <p:nvPr/>
+      </p:nvGrpSpPr>
+      <p:grpSpPr>
+        <a:xfrm>
+          <a:off x="0" y="0"/>
+          <a:ext cx="0" cy="0"/>
+          <a:chOff x="0" y="0"/>
+          <a:chExt cx="0" cy="0"/>
+        </a:xfrm>
+      </p:grpSpPr>
+      <p:cxnSp>
+        <p:nvCxnSpPr>
+          <p:cNvPr id="6" name="Connecteur droit avec flèche 5"/>
+          <p:cNvCxnSpPr/>
+          <p:nvPr/>
+        </p:nvCxnSpPr>
+        <p:spPr>
+          <a:xfrm>
+            <a:off x="2411760" y="3429000"/>
+            <a:ext cx="1454894" cy="0"/>
+          </a:xfrm>
+          <a:prstGeom prst="straightConnector1">
+            <a:avLst/>
+          </a:prstGeom>
+          <a:ln>
+            <a:solidFill>
+              <a:srgbClr val="002060"/>
+            </a:solidFill>
+            <a:tailEnd type="stealth" w="med" len="lg"/>
+          </a:ln>
+        </p:spPr>
+        <p:style>
+          <a:lnRef idx="1">
+            <a:schemeClr val="accent1"/>
+          </a:lnRef>
+          <a:fillRef idx="0">
+            <a:schemeClr val="accent1"/>
+          </a:fillRef>
+          <a:effectRef idx="0">
+            <a:schemeClr val="accent1"/>
+          </a:effectRef>
+          <a:fontRef idx="minor">
+            <a:schemeClr val="tx1"/>
+          </a:fontRef>
+        </p:style>
+      </p:cxnSp>
+      <mc:AlternateContent xmlns:mc="http://schemas.openxmlformats.org/markup-compatibility/2006">
+        <mc:Choice xmlns:a14="http://schemas.microsoft.com/office/drawing/2010/main" Requires="a14">
+          <p:sp>
+            <p:nvSpPr>
+              <p:cNvPr id="8" name="ZoneTexte 7"/>
+              <p:cNvSpPr txBox="1"/>
+              <p:nvPr/>
+            </p:nvSpPr>
+            <p:spPr>
+              <a:xfrm>
+                <a:off x="3139207" y="1838093"/>
+                <a:ext cx="328808" cy="307777"/>
+              </a:xfrm>
+              <a:prstGeom prst="rect">
+                <a:avLst/>
+              </a:prstGeom>
+              <a:noFill/>
+            </p:spPr>
+            <p:txBody>
+              <a:bodyPr wrap="none" rtlCol="0">
+                <a:spAutoFit/>
+              </a:bodyPr>
+              <a:lstStyle/>
+              <a:p>
+                <a:pPr/>
+                <a14:m>
+                  <m:oMathPara xmlns:m="http://schemas.openxmlformats.org/officeDocument/2006/math">
+                    <m:oMathParaPr>
+                      <m:jc m:val="centerGroup"/>
+                    </m:oMathParaPr>
+                    <m:oMath xmlns:m="http://schemas.openxmlformats.org/officeDocument/2006/math">
+                      <m:acc>
+                        <m:accPr>
+                          <m:chr m:val="⃗"/>
+                          <m:ctrlPr>
+                            <a:rPr lang="fr-FR" sz="1400" i="1" smtClean="0">
+                              <a:latin typeface="Cambria Math"/>
+                            </a:rPr>
+                          </m:ctrlPr>
+                        </m:accPr>
+                        <m:e>
+                          <m:r>
+                            <a:rPr lang="fr-FR" sz="1400" b="0" i="1" smtClean="0">
+                              <a:latin typeface="Cambria Math"/>
+                            </a:rPr>
+                            <m:t>𝑦</m:t>
+                          </m:r>
+                        </m:e>
+                      </m:acc>
+                    </m:oMath>
+                  </m:oMathPara>
+                </a14:m>
+                <a:endParaRPr lang="fr-FR" sz="1400" dirty="0"/>
+              </a:p>
+            </p:txBody>
+          </p:sp>
+        </mc:Choice>
+        <mc:Fallback>
+          <p:sp>
+            <p:nvSpPr>
               <p:cNvPr id="8" name="ZoneTexte 7"/>
               <p:cNvSpPr txBox="1">
                 <a:spLocks noRot="1" noChangeAspect="1" noMove="1" noResize="1" noEditPoints="1" noAdjustHandles="1" noChangeArrowheads="1" noChangeShapeType="1" noTextEdit="1"/>
@@ -3371,8 +3567,8 @@
             </p:nvSpPr>
             <p:spPr>
               <a:xfrm>
-                <a:off x="1637668" y="2242912"/>
-                <a:ext cx="314381" cy="307777"/>
+                <a:off x="3139207" y="1838093"/>
+                <a:ext cx="328808" cy="307777"/>
               </a:xfrm>
               <a:prstGeom prst="rect">
                 <a:avLst/>
@@ -3380,7 +3576,692 @@
               <a:blipFill rotWithShape="1">
                 <a:blip r:embed="rId2"/>
                 <a:stretch>
-                  <a:fillRect t="-12000" r="-11765"/>
+                  <a:fillRect t="-12000" r="-12963" b="-2000"/>
+                </a:stretch>
+              </a:blipFill>
+            </p:spPr>
+            <p:txBody>
+              <a:bodyPr/>
+              <a:lstStyle/>
+              <a:p>
+                <a:r>
+                  <a:rPr lang="fr-FR">
+                    <a:noFill/>
+                  </a:rPr>
+                  <a:t> </a:t>
+                </a:r>
+              </a:p>
+            </p:txBody>
+          </p:sp>
+        </mc:Fallback>
+      </mc:AlternateContent>
+      <p:cxnSp>
+        <p:nvCxnSpPr>
+          <p:cNvPr id="10" name="Connecteur droit avec flèche 9"/>
+          <p:cNvCxnSpPr/>
+          <p:nvPr/>
+        </p:nvCxnSpPr>
+        <p:spPr>
+          <a:xfrm flipV="1">
+            <a:off x="3139207" y="1916832"/>
+            <a:ext cx="0" cy="2952329"/>
+          </a:xfrm>
+          <a:prstGeom prst="straightConnector1">
+            <a:avLst/>
+          </a:prstGeom>
+          <a:ln>
+            <a:solidFill>
+              <a:srgbClr val="002060"/>
+            </a:solidFill>
+            <a:tailEnd type="stealth" w="med" len="lg"/>
+          </a:ln>
+        </p:spPr>
+        <p:style>
+          <a:lnRef idx="1">
+            <a:schemeClr val="accent1"/>
+          </a:lnRef>
+          <a:fillRef idx="0">
+            <a:schemeClr val="accent1"/>
+          </a:fillRef>
+          <a:effectRef idx="0">
+            <a:schemeClr val="accent1"/>
+          </a:effectRef>
+          <a:fontRef idx="minor">
+            <a:schemeClr val="tx1"/>
+          </a:fontRef>
+        </p:style>
+      </p:cxnSp>
+      <mc:AlternateContent xmlns:mc="http://schemas.openxmlformats.org/markup-compatibility/2006">
+        <mc:Choice xmlns:a14="http://schemas.microsoft.com/office/drawing/2010/main" Requires="a14">
+          <p:sp>
+            <p:nvSpPr>
+              <p:cNvPr id="11" name="ZoneTexte 10"/>
+              <p:cNvSpPr txBox="1"/>
+              <p:nvPr/>
+            </p:nvSpPr>
+            <p:spPr>
+              <a:xfrm>
+                <a:off x="3813581" y="3275111"/>
+                <a:ext cx="326371" cy="307777"/>
+              </a:xfrm>
+              <a:prstGeom prst="rect">
+                <a:avLst/>
+              </a:prstGeom>
+              <a:noFill/>
+            </p:spPr>
+            <p:txBody>
+              <a:bodyPr wrap="none" rtlCol="0">
+                <a:spAutoFit/>
+              </a:bodyPr>
+              <a:lstStyle/>
+              <a:p>
+                <a:pPr/>
+                <a14:m>
+                  <m:oMathPara xmlns:m="http://schemas.openxmlformats.org/officeDocument/2006/math">
+                    <m:oMathParaPr>
+                      <m:jc m:val="centerGroup"/>
+                    </m:oMathParaPr>
+                    <m:oMath xmlns:m="http://schemas.openxmlformats.org/officeDocument/2006/math">
+                      <m:acc>
+                        <m:accPr>
+                          <m:chr m:val="⃗"/>
+                          <m:ctrlPr>
+                            <a:rPr lang="fr-FR" sz="1400" i="1" smtClean="0">
+                              <a:latin typeface="Cambria Math"/>
+                            </a:rPr>
+                          </m:ctrlPr>
+                        </m:accPr>
+                        <m:e>
+                          <m:r>
+                            <a:rPr lang="fr-FR" sz="1400" b="0" i="1" smtClean="0">
+                              <a:latin typeface="Cambria Math"/>
+                            </a:rPr>
+                            <m:t>𝑥</m:t>
+                          </m:r>
+                        </m:e>
+                      </m:acc>
+                    </m:oMath>
+                  </m:oMathPara>
+                </a14:m>
+                <a:endParaRPr lang="fr-FR" sz="1400" dirty="0"/>
+              </a:p>
+            </p:txBody>
+          </p:sp>
+        </mc:Choice>
+        <mc:Fallback>
+          <p:sp>
+            <p:nvSpPr>
+              <p:cNvPr id="11" name="ZoneTexte 10"/>
+              <p:cNvSpPr txBox="1">
+                <a:spLocks noRot="1" noChangeAspect="1" noMove="1" noResize="1" noEditPoints="1" noAdjustHandles="1" noChangeArrowheads="1" noChangeShapeType="1" noTextEdit="1"/>
+              </p:cNvSpPr>
+              <p:nvPr/>
+            </p:nvSpPr>
+            <p:spPr>
+              <a:xfrm>
+                <a:off x="3813581" y="3275111"/>
+                <a:ext cx="326371" cy="307777"/>
+              </a:xfrm>
+              <a:prstGeom prst="rect">
+                <a:avLst/>
+              </a:prstGeom>
+              <a:blipFill rotWithShape="1">
+                <a:blip r:embed="rId3"/>
+                <a:stretch>
+                  <a:fillRect t="-11765" r="-11321"/>
+                </a:stretch>
+              </a:blipFill>
+            </p:spPr>
+            <p:txBody>
+              <a:bodyPr/>
+              <a:lstStyle/>
+              <a:p>
+                <a:r>
+                  <a:rPr lang="fr-FR">
+                    <a:noFill/>
+                  </a:rPr>
+                  <a:t> </a:t>
+                </a:r>
+              </a:p>
+            </p:txBody>
+          </p:sp>
+        </mc:Fallback>
+      </mc:AlternateContent>
+      <p:sp>
+        <p:nvSpPr>
+          <p:cNvPr id="12" name="Arc 11"/>
+          <p:cNvSpPr/>
+          <p:nvPr/>
+        </p:nvSpPr>
+        <p:spPr>
+          <a:xfrm>
+            <a:off x="1713781" y="1772816"/>
+            <a:ext cx="2850852" cy="2851168"/>
+          </a:xfrm>
+          <a:prstGeom prst="arc">
+            <a:avLst>
+              <a:gd name="adj1" fmla="val 4361367"/>
+              <a:gd name="adj2" fmla="val 6466550"/>
+            </a:avLst>
+          </a:prstGeom>
+          <a:ln w="9525">
+            <a:solidFill>
+              <a:srgbClr val="002060"/>
+            </a:solidFill>
+          </a:ln>
+        </p:spPr>
+        <p:style>
+          <a:lnRef idx="1">
+            <a:schemeClr val="accent1"/>
+          </a:lnRef>
+          <a:fillRef idx="0">
+            <a:schemeClr val="accent1"/>
+          </a:fillRef>
+          <a:effectRef idx="0">
+            <a:schemeClr val="accent1"/>
+          </a:effectRef>
+          <a:fontRef idx="minor">
+            <a:schemeClr val="tx1"/>
+          </a:fontRef>
+        </p:style>
+        <p:txBody>
+          <a:bodyPr rtlCol="0" anchor="ctr"/>
+          <a:lstStyle/>
+          <a:p>
+            <a:pPr algn="ctr"/>
+            <a:endParaRPr lang="fr-FR" dirty="0"/>
+          </a:p>
+        </p:txBody>
+      </p:sp>
+      <p:cxnSp>
+        <p:nvCxnSpPr>
+          <p:cNvPr id="18" name="Connecteur droit 17"/>
+          <p:cNvCxnSpPr/>
+          <p:nvPr/>
+        </p:nvCxnSpPr>
+        <p:spPr>
+          <a:xfrm>
+            <a:off x="2699792" y="2705398"/>
+            <a:ext cx="0" cy="1857632"/>
+          </a:xfrm>
+          <a:prstGeom prst="line">
+            <a:avLst/>
+          </a:prstGeom>
+          <a:ln w="9525">
+            <a:solidFill>
+              <a:srgbClr val="002060"/>
+            </a:solidFill>
+          </a:ln>
+        </p:spPr>
+        <p:style>
+          <a:lnRef idx="1">
+            <a:schemeClr val="accent1"/>
+          </a:lnRef>
+          <a:fillRef idx="0">
+            <a:schemeClr val="accent1"/>
+          </a:fillRef>
+          <a:effectRef idx="0">
+            <a:schemeClr val="accent1"/>
+          </a:effectRef>
+          <a:fontRef idx="minor">
+            <a:schemeClr val="tx1"/>
+          </a:fontRef>
+        </p:style>
+      </p:cxnSp>
+      <p:cxnSp>
+        <p:nvCxnSpPr>
+          <p:cNvPr id="13" name="Connecteur droit 12"/>
+          <p:cNvCxnSpPr/>
+          <p:nvPr/>
+        </p:nvCxnSpPr>
+        <p:spPr>
+          <a:xfrm>
+            <a:off x="3563888" y="2705398"/>
+            <a:ext cx="0" cy="1857632"/>
+          </a:xfrm>
+          <a:prstGeom prst="line">
+            <a:avLst/>
+          </a:prstGeom>
+          <a:ln w="9525">
+            <a:solidFill>
+              <a:srgbClr val="002060"/>
+            </a:solidFill>
+          </a:ln>
+        </p:spPr>
+        <p:style>
+          <a:lnRef idx="1">
+            <a:schemeClr val="accent1"/>
+          </a:lnRef>
+          <a:fillRef idx="0">
+            <a:schemeClr val="accent1"/>
+          </a:fillRef>
+          <a:effectRef idx="0">
+            <a:schemeClr val="accent1"/>
+          </a:effectRef>
+          <a:fontRef idx="minor">
+            <a:schemeClr val="tx1"/>
+          </a:fontRef>
+        </p:style>
+      </p:cxnSp>
+      <p:sp>
+        <p:nvSpPr>
+          <p:cNvPr id="14" name="Arc 13"/>
+          <p:cNvSpPr/>
+          <p:nvPr/>
+        </p:nvSpPr>
+        <p:spPr>
+          <a:xfrm>
+            <a:off x="2625732" y="1730416"/>
+            <a:ext cx="2850852" cy="2851168"/>
+          </a:xfrm>
+          <a:prstGeom prst="arc">
+            <a:avLst>
+              <a:gd name="adj1" fmla="val 11856006"/>
+              <a:gd name="adj2" fmla="val 13802256"/>
+            </a:avLst>
+          </a:prstGeom>
+          <a:ln w="9525">
+            <a:solidFill>
+              <a:srgbClr val="002060"/>
+            </a:solidFill>
+          </a:ln>
+        </p:spPr>
+        <p:style>
+          <a:lnRef idx="1">
+            <a:schemeClr val="accent1"/>
+          </a:lnRef>
+          <a:fillRef idx="0">
+            <a:schemeClr val="accent1"/>
+          </a:fillRef>
+          <a:effectRef idx="0">
+            <a:schemeClr val="accent1"/>
+          </a:effectRef>
+          <a:fontRef idx="minor">
+            <a:schemeClr val="tx1"/>
+          </a:fontRef>
+        </p:style>
+        <p:txBody>
+          <a:bodyPr rtlCol="0" anchor="ctr"/>
+          <a:lstStyle/>
+          <a:p>
+            <a:pPr algn="ctr"/>
+            <a:endParaRPr lang="fr-FR" dirty="0"/>
+          </a:p>
+        </p:txBody>
+      </p:sp>
+      <p:sp>
+        <p:nvSpPr>
+          <p:cNvPr id="16" name="Arc 15"/>
+          <p:cNvSpPr/>
+          <p:nvPr/>
+        </p:nvSpPr>
+        <p:spPr>
+          <a:xfrm flipH="1">
+            <a:off x="780976" y="1730540"/>
+            <a:ext cx="2850852" cy="2851168"/>
+          </a:xfrm>
+          <a:prstGeom prst="arc">
+            <a:avLst>
+              <a:gd name="adj1" fmla="val 11856006"/>
+              <a:gd name="adj2" fmla="val 13802256"/>
+            </a:avLst>
+          </a:prstGeom>
+          <a:ln w="9525">
+            <a:solidFill>
+              <a:srgbClr val="002060"/>
+            </a:solidFill>
+          </a:ln>
+        </p:spPr>
+        <p:style>
+          <a:lnRef idx="1">
+            <a:schemeClr val="accent1"/>
+          </a:lnRef>
+          <a:fillRef idx="0">
+            <a:schemeClr val="accent1"/>
+          </a:fillRef>
+          <a:effectRef idx="0">
+            <a:schemeClr val="accent1"/>
+          </a:effectRef>
+          <a:fontRef idx="minor">
+            <a:schemeClr val="tx1"/>
+          </a:fontRef>
+        </p:style>
+        <p:txBody>
+          <a:bodyPr rtlCol="0" anchor="ctr"/>
+          <a:lstStyle/>
+          <a:p>
+            <a:pPr algn="ctr"/>
+            <a:endParaRPr lang="fr-FR" dirty="0"/>
+          </a:p>
+        </p:txBody>
+      </p:sp>
+      <p:sp>
+        <p:nvSpPr>
+          <p:cNvPr id="9" name="Ellipse 8"/>
+          <p:cNvSpPr/>
+          <p:nvPr/>
+        </p:nvSpPr>
+        <p:spPr>
+          <a:xfrm>
+            <a:off x="2974803" y="2703564"/>
+            <a:ext cx="328808" cy="328808"/>
+          </a:xfrm>
+          <a:prstGeom prst="ellipse">
+            <a:avLst/>
+          </a:prstGeom>
+          <a:ln w="9525">
+            <a:solidFill>
+              <a:srgbClr val="002060"/>
+            </a:solidFill>
+          </a:ln>
+        </p:spPr>
+        <p:style>
+          <a:lnRef idx="1">
+            <a:schemeClr val="accent1"/>
+          </a:lnRef>
+          <a:fillRef idx="0">
+            <a:schemeClr val="accent1"/>
+          </a:fillRef>
+          <a:effectRef idx="0">
+            <a:schemeClr val="accent1"/>
+          </a:effectRef>
+          <a:fontRef idx="minor">
+            <a:schemeClr val="tx1"/>
+          </a:fontRef>
+        </p:style>
+        <p:txBody>
+          <a:bodyPr rtlCol="0" anchor="ctr"/>
+          <a:lstStyle/>
+          <a:p>
+            <a:pPr algn="ctr"/>
+            <a:endParaRPr lang="fr-FR">
+              <a:solidFill>
+                <a:schemeClr val="tx1"/>
+              </a:solidFill>
+            </a:endParaRPr>
+          </a:p>
+        </p:txBody>
+      </p:sp>
+      <p:sp>
+        <p:nvSpPr>
+          <p:cNvPr id="19" name="Ellipse 18"/>
+          <p:cNvSpPr/>
+          <p:nvPr/>
+        </p:nvSpPr>
+        <p:spPr>
+          <a:xfrm>
+            <a:off x="2974803" y="3789040"/>
+            <a:ext cx="328808" cy="328808"/>
+          </a:xfrm>
+          <a:prstGeom prst="ellipse">
+            <a:avLst/>
+          </a:prstGeom>
+          <a:ln w="9525">
+            <a:solidFill>
+              <a:srgbClr val="002060"/>
+            </a:solidFill>
+          </a:ln>
+        </p:spPr>
+        <p:style>
+          <a:lnRef idx="1">
+            <a:schemeClr val="accent1"/>
+          </a:lnRef>
+          <a:fillRef idx="0">
+            <a:schemeClr val="accent1"/>
+          </a:fillRef>
+          <a:effectRef idx="0">
+            <a:schemeClr val="accent1"/>
+          </a:effectRef>
+          <a:fontRef idx="minor">
+            <a:schemeClr val="tx1"/>
+          </a:fontRef>
+        </p:style>
+        <p:txBody>
+          <a:bodyPr rtlCol="0" anchor="ctr"/>
+          <a:lstStyle/>
+          <a:p>
+            <a:pPr algn="ctr"/>
+            <a:endParaRPr lang="fr-FR">
+              <a:solidFill>
+                <a:schemeClr val="tx1"/>
+              </a:solidFill>
+            </a:endParaRPr>
+          </a:p>
+        </p:txBody>
+      </p:sp>
+      <p:sp>
+        <p:nvSpPr>
+          <p:cNvPr id="20" name="Arc 19"/>
+          <p:cNvSpPr/>
+          <p:nvPr/>
+        </p:nvSpPr>
+        <p:spPr>
+          <a:xfrm>
+            <a:off x="2908176" y="2636912"/>
+            <a:ext cx="462062" cy="462112"/>
+          </a:xfrm>
+          <a:prstGeom prst="arc">
+            <a:avLst>
+              <a:gd name="adj1" fmla="val 8882735"/>
+              <a:gd name="adj2" fmla="val 15370082"/>
+            </a:avLst>
+          </a:prstGeom>
+          <a:ln>
+            <a:solidFill>
+              <a:srgbClr val="002060"/>
+            </a:solidFill>
+            <a:tailEnd type="stealth" w="med" len="lg"/>
+          </a:ln>
+        </p:spPr>
+        <p:style>
+          <a:lnRef idx="1">
+            <a:schemeClr val="accent1"/>
+          </a:lnRef>
+          <a:fillRef idx="0">
+            <a:schemeClr val="accent1"/>
+          </a:fillRef>
+          <a:effectRef idx="0">
+            <a:schemeClr val="accent1"/>
+          </a:effectRef>
+          <a:fontRef idx="minor">
+            <a:schemeClr val="tx1"/>
+          </a:fontRef>
+        </p:style>
+        <p:txBody>
+          <a:bodyPr rtlCol="0" anchor="ctr"/>
+          <a:lstStyle/>
+          <a:p>
+            <a:pPr algn="ctr"/>
+            <a:endParaRPr lang="fr-FR" dirty="0"/>
+          </a:p>
+        </p:txBody>
+      </p:sp>
+      <p:sp>
+        <p:nvSpPr>
+          <p:cNvPr id="21" name="Arc 20"/>
+          <p:cNvSpPr/>
+          <p:nvPr/>
+        </p:nvSpPr>
+        <p:spPr>
+          <a:xfrm>
+            <a:off x="2908176" y="3722388"/>
+            <a:ext cx="462062" cy="462112"/>
+          </a:xfrm>
+          <a:prstGeom prst="arc">
+            <a:avLst>
+              <a:gd name="adj1" fmla="val 8882735"/>
+              <a:gd name="adj2" fmla="val 15370082"/>
+            </a:avLst>
+          </a:prstGeom>
+          <a:ln>
+            <a:solidFill>
+              <a:srgbClr val="002060"/>
+            </a:solidFill>
+            <a:tailEnd type="stealth" w="med" len="lg"/>
+          </a:ln>
+        </p:spPr>
+        <p:style>
+          <a:lnRef idx="1">
+            <a:schemeClr val="accent1"/>
+          </a:lnRef>
+          <a:fillRef idx="0">
+            <a:schemeClr val="accent1"/>
+          </a:fillRef>
+          <a:effectRef idx="0">
+            <a:schemeClr val="accent1"/>
+          </a:effectRef>
+          <a:fontRef idx="minor">
+            <a:schemeClr val="tx1"/>
+          </a:fontRef>
+        </p:style>
+        <p:txBody>
+          <a:bodyPr rtlCol="0" anchor="ctr"/>
+          <a:lstStyle/>
+          <a:p>
+            <a:pPr algn="ctr"/>
+            <a:endParaRPr lang="fr-FR" dirty="0"/>
+          </a:p>
+        </p:txBody>
+      </p:sp>
+      <p:cxnSp>
+        <p:nvCxnSpPr>
+          <p:cNvPr id="22" name="Connecteur droit avec flèche 21"/>
+          <p:cNvCxnSpPr/>
+          <p:nvPr/>
+        </p:nvCxnSpPr>
+        <p:spPr>
+          <a:xfrm>
+            <a:off x="1713781" y="3429000"/>
+            <a:ext cx="492621" cy="0"/>
+          </a:xfrm>
+          <a:prstGeom prst="straightConnector1">
+            <a:avLst/>
+          </a:prstGeom>
+          <a:ln w="19050">
+            <a:solidFill>
+              <a:srgbClr val="002060"/>
+            </a:solidFill>
+            <a:tailEnd type="stealth" w="med" len="lg"/>
+          </a:ln>
+        </p:spPr>
+        <p:style>
+          <a:lnRef idx="1">
+            <a:schemeClr val="accent1"/>
+          </a:lnRef>
+          <a:fillRef idx="0">
+            <a:schemeClr val="accent1"/>
+          </a:fillRef>
+          <a:effectRef idx="0">
+            <a:schemeClr val="accent1"/>
+          </a:effectRef>
+          <a:fontRef idx="minor">
+            <a:schemeClr val="tx1"/>
+          </a:fontRef>
+        </p:style>
+      </p:cxnSp>
+      <mc:AlternateContent xmlns:mc="http://schemas.openxmlformats.org/markup-compatibility/2006">
+        <mc:Choice xmlns:a14="http://schemas.microsoft.com/office/drawing/2010/main" Requires="a14">
+          <p:sp>
+            <p:nvSpPr>
+              <p:cNvPr id="23" name="ZoneTexte 22"/>
+              <p:cNvSpPr txBox="1"/>
+              <p:nvPr/>
+            </p:nvSpPr>
+            <p:spPr>
+              <a:xfrm>
+                <a:off x="1708895" y="3121223"/>
+                <a:ext cx="497507" cy="307777"/>
+              </a:xfrm>
+              <a:prstGeom prst="rect">
+                <a:avLst/>
+              </a:prstGeom>
+              <a:noFill/>
+            </p:spPr>
+            <p:txBody>
+              <a:bodyPr wrap="none" rtlCol="0">
+                <a:spAutoFit/>
+              </a:bodyPr>
+              <a:lstStyle/>
+              <a:p>
+                <a:pPr/>
+                <a14:m>
+                  <m:oMathPara xmlns:m="http://schemas.openxmlformats.org/officeDocument/2006/math">
+                    <m:oMathParaPr>
+                      <m:jc m:val="centerGroup"/>
+                    </m:oMathParaPr>
+                    <m:oMath xmlns:m="http://schemas.openxmlformats.org/officeDocument/2006/math">
+                      <m:sSub>
+                        <m:sSubPr>
+                          <m:ctrlPr>
+                            <a:rPr lang="fr-FR" sz="1400" b="0" i="1" smtClean="0">
+                              <a:latin typeface="Cambria Math"/>
+                            </a:rPr>
+                          </m:ctrlPr>
+                        </m:sSubPr>
+                        <m:e>
+                          <m:r>
+                            <a:rPr lang="fr-FR" sz="1400" b="0" i="1" smtClean="0">
+                              <a:latin typeface="Cambria Math"/>
+                            </a:rPr>
+                            <m:t>𝑉</m:t>
+                          </m:r>
+                        </m:e>
+                        <m:sub>
+                          <m:r>
+                            <a:rPr lang="fr-FR" sz="1400" b="0" i="1" smtClean="0">
+                              <a:latin typeface="Cambria Math"/>
+                            </a:rPr>
+                            <m:t>0</m:t>
+                          </m:r>
+                        </m:sub>
+                      </m:sSub>
+                      <m:acc>
+                        <m:accPr>
+                          <m:chr m:val="⃗"/>
+                          <m:ctrlPr>
+                            <a:rPr lang="fr-FR" sz="1400" i="1" smtClean="0">
+                              <a:latin typeface="Cambria Math"/>
+                            </a:rPr>
+                          </m:ctrlPr>
+                        </m:accPr>
+                        <m:e>
+                          <m:r>
+                            <a:rPr lang="fr-FR" sz="1400" b="0" i="1" smtClean="0">
+                              <a:latin typeface="Cambria Math"/>
+                            </a:rPr>
+                            <m:t>𝑥</m:t>
+                          </m:r>
+                        </m:e>
+                      </m:acc>
+                    </m:oMath>
+                  </m:oMathPara>
+                </a14:m>
+                <a:endParaRPr lang="fr-FR" sz="1400" dirty="0"/>
+              </a:p>
+            </p:txBody>
+          </p:sp>
+        </mc:Choice>
+        <mc:Fallback>
+          <p:sp>
+            <p:nvSpPr>
+              <p:cNvPr id="23" name="ZoneTexte 22"/>
+              <p:cNvSpPr txBox="1">
+                <a:spLocks noRot="1" noChangeAspect="1" noMove="1" noResize="1" noEditPoints="1" noAdjustHandles="1" noChangeArrowheads="1" noChangeShapeType="1" noTextEdit="1"/>
+              </p:cNvSpPr>
+              <p:nvPr/>
+            </p:nvSpPr>
+            <p:spPr>
+              <a:xfrm>
+                <a:off x="1708895" y="3121223"/>
+                <a:ext cx="497507" cy="307777"/>
+              </a:xfrm>
+              <a:prstGeom prst="rect">
+                <a:avLst/>
+              </a:prstGeom>
+              <a:blipFill rotWithShape="1">
+                <a:blip r:embed="rId4"/>
+                <a:stretch>
+                  <a:fillRect t="-11765" r="-32927"/>
                 </a:stretch>
               </a:blipFill>
             </p:spPr>
@@ -3400,6 +4281,11 @@
         </mc:Fallback>
       </mc:AlternateContent>
     </p:spTree>
+    <p:extLst>
+      <p:ext uri="{BB962C8B-B14F-4D97-AF65-F5344CB8AC3E}">
+        <p14:creationId xmlns:p14="http://schemas.microsoft.com/office/powerpoint/2010/main" val="1085903030"/>
+      </p:ext>
+    </p:extLst>
   </p:cSld>
   <p:clrMapOvr>
     <a:masterClrMapping/>
@@ -3407,7 +4293,7 @@
 </p:sld>
 </file>
 
-<file path=ppt/slides/slide2.xml><?xml version="1.0" encoding="utf-8"?>
+<file path=ppt/slides/slide3.xml><?xml version="1.0" encoding="utf-8"?>
 <p:sld xmlns:a="http://schemas.openxmlformats.org/drawingml/2006/main" xmlns:r="http://schemas.openxmlformats.org/officeDocument/2006/relationships" xmlns:p="http://schemas.openxmlformats.org/presentationml/2006/main">
   <p:cSld>
     <p:spTree>
@@ -3531,8 +4417,8 @@
           </a:fontRef>
         </p:style>
       </p:cxnSp>
-      <mc:AlternateContent xmlns:mc="http://schemas.openxmlformats.org/markup-compatibility/2006">
-        <mc:Choice xmlns:a14="http://schemas.microsoft.com/office/drawing/2010/main" Requires="a14">
+      <mc:AlternateContent xmlns:mc="http://schemas.openxmlformats.org/markup-compatibility/2006" xmlns:a14="http://schemas.microsoft.com/office/drawing/2010/main">
+        <mc:Choice Requires="a14">
           <p:sp>
             <p:nvSpPr>
               <p:cNvPr id="10" name="ZoneTexte 9"/>
@@ -3555,6 +4441,7 @@
               </a:bodyPr>
               <a:lstStyle/>
               <a:p>
+                <a:pPr/>
                 <a14:m>
                   <m:oMathPara xmlns:m="http://schemas.openxmlformats.org/officeDocument/2006/math">
                     <m:oMathParaPr>
@@ -3587,7 +4474,7 @@
             </p:txBody>
           </p:sp>
         </mc:Choice>
-        <mc:Fallback>
+        <mc:Fallback xmlns="">
           <p:sp>
             <p:nvSpPr>
               <p:cNvPr id="10" name="ZoneTexte 9"/>
@@ -3626,8 +4513,8 @@
           </p:sp>
         </mc:Fallback>
       </mc:AlternateContent>
-      <mc:AlternateContent xmlns:mc="http://schemas.openxmlformats.org/markup-compatibility/2006">
-        <mc:Choice xmlns:a14="http://schemas.microsoft.com/office/drawing/2010/main" Requires="a14">
+      <mc:AlternateContent xmlns:mc="http://schemas.openxmlformats.org/markup-compatibility/2006" xmlns:a14="http://schemas.microsoft.com/office/drawing/2010/main">
+        <mc:Choice Requires="a14">
           <p:sp>
             <p:nvSpPr>
               <p:cNvPr id="12" name="ZoneTexte 11"/>
@@ -3650,6 +4537,7 @@
               </a:bodyPr>
               <a:lstStyle/>
               <a:p>
+                <a:pPr/>
                 <a14:m>
                   <m:oMathPara xmlns:m="http://schemas.openxmlformats.org/officeDocument/2006/math">
                     <m:oMathParaPr>
@@ -3682,7 +4570,7 @@
             </p:txBody>
           </p:sp>
         </mc:Choice>
-        <mc:Fallback>
+        <mc:Fallback xmlns="">
           <p:sp>
             <p:nvSpPr>
               <p:cNvPr id="12" name="ZoneTexte 11"/>
@@ -3980,8 +4868,8 @@
           </a:fontRef>
         </p:style>
       </p:cxnSp>
-      <mc:AlternateContent xmlns:mc="http://schemas.openxmlformats.org/markup-compatibility/2006">
-        <mc:Choice xmlns:a14="http://schemas.microsoft.com/office/drawing/2010/main" Requires="a14">
+      <mc:AlternateContent xmlns:mc="http://schemas.openxmlformats.org/markup-compatibility/2006" xmlns:a14="http://schemas.microsoft.com/office/drawing/2010/main">
+        <mc:Choice Requires="a14">
           <p:sp>
             <p:nvSpPr>
               <p:cNvPr id="23" name="ZoneTexte 22"/>
@@ -4004,6 +4892,7 @@
               </a:bodyPr>
               <a:lstStyle/>
               <a:p>
+                <a:pPr/>
                 <a14:m>
                   <m:oMathPara xmlns:m="http://schemas.openxmlformats.org/officeDocument/2006/math">
                     <m:oMathParaPr>
@@ -4036,7 +4925,7 @@
             </p:txBody>
           </p:sp>
         </mc:Choice>
-        <mc:Fallback>
+        <mc:Fallback xmlns="">
           <p:sp>
             <p:nvSpPr>
               <p:cNvPr id="23" name="ZoneTexte 22"/>
@@ -4075,8 +4964,8 @@
           </p:sp>
         </mc:Fallback>
       </mc:AlternateContent>
-      <mc:AlternateContent xmlns:mc="http://schemas.openxmlformats.org/markup-compatibility/2006">
-        <mc:Choice xmlns:a14="http://schemas.microsoft.com/office/drawing/2010/main" Requires="a14">
+      <mc:AlternateContent xmlns:mc="http://schemas.openxmlformats.org/markup-compatibility/2006" xmlns:a14="http://schemas.microsoft.com/office/drawing/2010/main">
+        <mc:Choice Requires="a14">
           <p:sp>
             <p:nvSpPr>
               <p:cNvPr id="24" name="ZoneTexte 23"/>
@@ -4099,6 +4988,7 @@
               </a:bodyPr>
               <a:lstStyle/>
               <a:p>
+                <a:pPr/>
                 <a14:m>
                   <m:oMathPara xmlns:m="http://schemas.openxmlformats.org/officeDocument/2006/math">
                     <m:oMathParaPr>
@@ -4119,7 +5009,7 @@
             </p:txBody>
           </p:sp>
         </mc:Choice>
-        <mc:Fallback>
+        <mc:Fallback xmlns="">
           <p:sp>
             <p:nvSpPr>
               <p:cNvPr id="24" name="ZoneTexte 23"/>
@@ -4195,8 +5085,8 @@
           </a:fontRef>
         </p:style>
       </p:cxnSp>
-      <mc:AlternateContent xmlns:mc="http://schemas.openxmlformats.org/markup-compatibility/2006">
-        <mc:Choice xmlns:a14="http://schemas.microsoft.com/office/drawing/2010/main" Requires="a14">
+      <mc:AlternateContent xmlns:mc="http://schemas.openxmlformats.org/markup-compatibility/2006" xmlns:a14="http://schemas.microsoft.com/office/drawing/2010/main">
+        <mc:Choice Requires="a14">
           <p:sp>
             <p:nvSpPr>
               <p:cNvPr id="28" name="ZoneTexte 27"/>
@@ -4219,6 +5109,7 @@
               </a:bodyPr>
               <a:lstStyle/>
               <a:p>
+                <a:pPr/>
                 <a14:m>
                   <m:oMathPara xmlns:m="http://schemas.openxmlformats.org/officeDocument/2006/math">
                     <m:oMathParaPr>
@@ -4239,7 +5130,7 @@
             </p:txBody>
           </p:sp>
         </mc:Choice>
-        <mc:Fallback>
+        <mc:Fallback xmlns="">
           <p:sp>
             <p:nvSpPr>
               <p:cNvPr id="28" name="ZoneTexte 27"/>
@@ -4326,8 +5217,8 @@
           </a:p>
         </p:txBody>
       </p:sp>
-      <mc:AlternateContent xmlns:mc="http://schemas.openxmlformats.org/markup-compatibility/2006">
-        <mc:Choice xmlns:a14="http://schemas.microsoft.com/office/drawing/2010/main" Requires="a14">
+      <mc:AlternateContent xmlns:mc="http://schemas.openxmlformats.org/markup-compatibility/2006" xmlns:a14="http://schemas.microsoft.com/office/drawing/2010/main">
+        <mc:Choice Requires="a14">
           <p:sp>
             <p:nvSpPr>
               <p:cNvPr id="30" name="ZoneTexte 29"/>
@@ -4350,6 +5241,7 @@
               </a:bodyPr>
               <a:lstStyle/>
               <a:p>
+                <a:pPr/>
                 <a14:m>
                   <m:oMathPara xmlns:m="http://schemas.openxmlformats.org/officeDocument/2006/math">
                     <m:oMathParaPr>
@@ -4370,7 +5262,7 @@
             </p:txBody>
           </p:sp>
         </mc:Choice>
-        <mc:Fallback>
+        <mc:Fallback xmlns="">
           <p:sp>
             <p:nvSpPr>
               <p:cNvPr id="30" name="ZoneTexte 29"/>
@@ -4409,8 +5301,8 @@
           </p:sp>
         </mc:Fallback>
       </mc:AlternateContent>
-      <mc:AlternateContent xmlns:mc="http://schemas.openxmlformats.org/markup-compatibility/2006">
-        <mc:Choice xmlns:a14="http://schemas.microsoft.com/office/drawing/2010/main" Requires="a14">
+      <mc:AlternateContent xmlns:mc="http://schemas.openxmlformats.org/markup-compatibility/2006" xmlns:a14="http://schemas.microsoft.com/office/drawing/2010/main">
+        <mc:Choice Requires="a14">
           <p:sp>
             <p:nvSpPr>
               <p:cNvPr id="31" name="ZoneTexte 30"/>
@@ -4433,6 +5325,7 @@
               </a:bodyPr>
               <a:lstStyle/>
               <a:p>
+                <a:pPr/>
                 <a14:m>
                   <m:oMathPara xmlns:m="http://schemas.openxmlformats.org/officeDocument/2006/math">
                     <m:oMathParaPr>
@@ -4453,7 +5346,7 @@
             </p:txBody>
           </p:sp>
         </mc:Choice>
-        <mc:Fallback>
+        <mc:Fallback xmlns="">
           <p:sp>
             <p:nvSpPr>
               <p:cNvPr id="31" name="ZoneTexte 30"/>
@@ -4492,8 +5385,8 @@
           </p:sp>
         </mc:Fallback>
       </mc:AlternateContent>
-      <mc:AlternateContent xmlns:mc="http://schemas.openxmlformats.org/markup-compatibility/2006">
-        <mc:Choice xmlns:a14="http://schemas.microsoft.com/office/drawing/2010/main" Requires="a14">
+      <mc:AlternateContent xmlns:mc="http://schemas.openxmlformats.org/markup-compatibility/2006" xmlns:a14="http://schemas.microsoft.com/office/drawing/2010/main">
+        <mc:Choice Requires="a14">
           <p:sp>
             <p:nvSpPr>
               <p:cNvPr id="32" name="ZoneTexte 31"/>
@@ -4516,6 +5409,7 @@
               </a:bodyPr>
               <a:lstStyle/>
               <a:p>
+                <a:pPr/>
                 <a14:m>
                   <m:oMathPara xmlns:m="http://schemas.openxmlformats.org/officeDocument/2006/math">
                     <m:oMathParaPr>
@@ -4536,7 +5430,7 @@
             </p:txBody>
           </p:sp>
         </mc:Choice>
-        <mc:Fallback>
+        <mc:Fallback xmlns="">
           <p:sp>
             <p:nvSpPr>
               <p:cNvPr id="32" name="ZoneTexte 31"/>
@@ -4646,8 +5540,8 @@
           </a:fontRef>
         </p:style>
       </p:cxnSp>
-      <mc:AlternateContent xmlns:mc="http://schemas.openxmlformats.org/markup-compatibility/2006">
-        <mc:Choice xmlns:a14="http://schemas.microsoft.com/office/drawing/2010/main" Requires="a14">
+      <mc:AlternateContent xmlns:mc="http://schemas.openxmlformats.org/markup-compatibility/2006" xmlns:a14="http://schemas.microsoft.com/office/drawing/2010/main">
+        <mc:Choice Requires="a14">
           <p:sp>
             <p:nvSpPr>
               <p:cNvPr id="39" name="ZoneTexte 38"/>
@@ -4670,6 +5564,7 @@
               </a:bodyPr>
               <a:lstStyle/>
               <a:p>
+                <a:pPr/>
                 <a14:m>
                   <m:oMathPara xmlns:m="http://schemas.openxmlformats.org/officeDocument/2006/math">
                     <m:oMathParaPr>
@@ -4690,7 +5585,7 @@
             </p:txBody>
           </p:sp>
         </mc:Choice>
-        <mc:Fallback>
+        <mc:Fallback xmlns="">
           <p:sp>
             <p:nvSpPr>
               <p:cNvPr id="39" name="ZoneTexte 38"/>

</xml_diff>